<commit_message>
slides(claude-tool-use): refresh ch08 deck for G0 blockers
</commit_message>
<xml_diff>
--- a/vault/courses/claude-tool-use-from-zero/ch08-slides.pptx
+++ b/vault/courses/claude-tool-use-from-zero/ch08-slides.pptx
@@ -3104,57 +3104,14 @@
       <p:grpSpPr/>
       <p:sp>
         <p:nvSpPr>
-          <p:cNvPr id="2" name="Rectangle 1"/>
-          <p:cNvSpPr/>
-          <p:nvPr/>
-        </p:nvSpPr>
-        <p:spPr>
-          <a:xfrm>
-            <a:off x="0" y="0"/>
-            <a:ext cx="12191695" cy="109728"/>
-          </a:xfrm>
-          <a:prstGeom prst="rect">
-            <a:avLst/>
-          </a:prstGeom>
-          <a:solidFill>
-            <a:srgbClr val="A1A1AA"/>
-          </a:solidFill>
-          <a:ln>
-            <a:noFill/>
-          </a:ln>
-        </p:spPr>
-        <p:style>
-          <a:lnRef idx="1">
-            <a:schemeClr val="accent1"/>
-          </a:lnRef>
-          <a:fillRef idx="3">
-            <a:schemeClr val="accent1"/>
-          </a:fillRef>
-          <a:effectRef idx="2">
-            <a:schemeClr val="accent1"/>
-          </a:effectRef>
-          <a:fontRef idx="minor">
-            <a:schemeClr val="lt1"/>
-          </a:fontRef>
-        </p:style>
-        <p:txBody>
-          <a:bodyPr rtlCol="0" anchor="ctr"/>
-          <a:lstStyle/>
-          <a:p>
-            <a:pPr algn="ctr"/>
-          </a:p>
-        </p:txBody>
-      </p:sp>
-      <p:sp>
-        <p:nvSpPr>
-          <p:cNvPr id="3" name="TextBox 2"/>
+          <p:cNvPr id="2" name="TextBox 1"/>
           <p:cNvSpPr txBox="1"/>
           <p:nvPr/>
         </p:nvSpPr>
         <p:spPr>
           <a:xfrm>
-            <a:off x="777240" y="1051560"/>
-            <a:ext cx="10698480" cy="1051560"/>
+            <a:off x="914400" y="1828800"/>
+            <a:ext cx="10332720" cy="2286000"/>
           </a:xfrm>
           <a:prstGeom prst="rect">
             <a:avLst/>
@@ -3162,18 +3119,17 @@
           <a:noFill/>
         </p:spPr>
         <p:txBody>
-          <a:bodyPr wrap="none">
+          <a:bodyPr wrap="square">
             <a:spAutoFit/>
           </a:bodyPr>
           <a:lstStyle/>
           <a:p>
-            <a:pPr algn="l"/>
-            <a:r>
-              <a:rPr sz="4000" b="1">
+            <a:pPr algn="ctr"/>
+            <a:r>
+              <a:rPr sz="3400" b="1">
                 <a:solidFill>
                   <a:srgbClr val="FFFFFF"/>
                 </a:solidFill>
-                <a:latin typeface="Arial"/>
               </a:rPr>
               <a:t>Legal and Regulatory Connectors in MCP</a:t>
             </a:r>
@@ -3182,14 +3138,14 @@
       </p:sp>
       <p:sp>
         <p:nvSpPr>
-          <p:cNvPr id="4" name="TextBox 3"/>
+          <p:cNvPr id="3" name="TextBox 2"/>
           <p:cNvSpPr txBox="1"/>
           <p:nvPr/>
         </p:nvSpPr>
         <p:spPr>
           <a:xfrm>
-            <a:off x="822960" y="2029968"/>
-            <a:ext cx="9601200" cy="457200"/>
+            <a:off x="731520" y="6263640"/>
+            <a:ext cx="10698480" cy="365760"/>
           </a:xfrm>
           <a:prstGeom prst="rect">
             <a:avLst/>
@@ -3197,124 +3153,17 @@
           <a:noFill/>
         </p:spPr>
         <p:txBody>
-          <a:bodyPr wrap="none">
-            <a:spAutoFit/>
-          </a:bodyPr>
-          <a:lstStyle/>
-          <a:p>
-            <a:pPr algn="l"/>
-            <a:r>
-              <a:rPr sz="2100" b="0">
-                <a:solidFill>
-                  <a:srgbClr val="A1A1AA"/>
-                </a:solidFill>
-                <a:latin typeface="Arial"/>
-              </a:rPr>
-              <a:t>Chapter 8 · Claude Tool Use from Zero</a:t>
-            </a:r>
-          </a:p>
-        </p:txBody>
-      </p:sp>
-      <p:sp>
-        <p:nvSpPr>
-          <p:cNvPr id="5" name="TextBox 4"/>
-          <p:cNvSpPr txBox="1"/>
-          <p:nvPr/>
-        </p:nvSpPr>
-        <p:spPr>
-          <a:xfrm>
-            <a:off x="960120" y="2880360"/>
-            <a:ext cx="10241280" cy="4160520"/>
-          </a:xfrm>
-          <a:prstGeom prst="rect">
-            <a:avLst/>
-          </a:prstGeom>
-          <a:noFill/>
-        </p:spPr>
-        <p:txBody>
           <a:bodyPr wrap="square">
             <a:spAutoFit/>
           </a:bodyPr>
           <a:lstStyle/>
           <a:p>
-            <a:pPr>
-              <a:spcAft>
-                <a:spcPts val="1300"/>
-              </a:spcAft>
-              <a:defRPr sz="2300">
-                <a:solidFill>
-                  <a:srgbClr val="D4D4D8"/>
-                </a:solidFill>
-                <a:latin typeface="Arial"/>
-              </a:defRPr>
-            </a:pPr>
-            <a:r>
-              <a:t>Handle legal documents with confidentiality, auditability, and data residency constraints</a:t>
-            </a:r>
-          </a:p>
-          <a:p>
-            <a:pPr>
-              <a:spcAft>
-                <a:spcPts val="1300"/>
-              </a:spcAft>
-              <a:defRPr sz="2500">
-                <a:solidFill>
-                  <a:srgbClr val="D4D4D8"/>
-                </a:solidFill>
-                <a:latin typeface="Arial"/>
-              </a:defRPr>
-            </a:pPr>
-            <a:r>
-              <a:t>Build compliance-first tool definitions for legal practice management systems</a:t>
-            </a:r>
-          </a:p>
-          <a:p>
-            <a:pPr>
-              <a:spcAft>
-                <a:spcPts val="1300"/>
-              </a:spcAft>
-              <a:defRPr sz="2500">
-                <a:solidFill>
-                  <a:srgbClr val="D4D4D8"/>
-                </a:solidFill>
-                <a:latin typeface="Arial"/>
-              </a:defRPr>
-            </a:pPr>
-            <a:r>
-              <a:t>Use deterministic local redaction before analysis workflows</a:t>
-            </a:r>
-          </a:p>
-        </p:txBody>
-      </p:sp>
-      <p:sp>
-        <p:nvSpPr>
-          <p:cNvPr id="6" name="TextBox 5"/>
-          <p:cNvSpPr txBox="1"/>
-          <p:nvPr/>
-        </p:nvSpPr>
-        <p:spPr>
-          <a:xfrm>
-            <a:off x="822960" y="6263640"/>
-            <a:ext cx="6583680" cy="256032"/>
-          </a:xfrm>
-          <a:prstGeom prst="rect">
-            <a:avLst/>
-          </a:prstGeom>
-          <a:noFill/>
-        </p:spPr>
-        <p:txBody>
-          <a:bodyPr wrap="none">
-            <a:spAutoFit/>
-          </a:bodyPr>
-          <a:lstStyle/>
-          <a:p>
             <a:pPr algn="l"/>
             <a:r>
-              <a:rPr sz="1200" b="0">
+              <a:rPr sz="1000" b="0">
                 <a:solidFill>
                   <a:srgbClr val="A1A1AA"/>
                 </a:solidFill>
-                <a:latin typeface="Arial"/>
               </a:rPr>
               <a:t>academy.kspl.tech | Koenig AI Academy</a:t>
             </a:r>
@@ -3349,14 +3198,48 @@
       <p:grpSpPr/>
       <p:sp>
         <p:nvSpPr>
-          <p:cNvPr id="2" name="Rectangle 1"/>
+          <p:cNvPr id="2" name="TextBox 1"/>
+          <p:cNvSpPr txBox="1"/>
+          <p:nvPr/>
+        </p:nvSpPr>
+        <p:spPr>
+          <a:xfrm>
+            <a:off x="731520" y="411480"/>
+            <a:ext cx="10698480" cy="1005840"/>
+          </a:xfrm>
+          <a:prstGeom prst="rect">
+            <a:avLst/>
+          </a:prstGeom>
+          <a:noFill/>
+        </p:spPr>
+        <p:txBody>
+          <a:bodyPr wrap="square">
+            <a:spAutoFit/>
+          </a:bodyPr>
+          <a:lstStyle/>
+          <a:p>
+            <a:pPr algn="l"/>
+            <a:r>
+              <a:rPr sz="2800" b="1">
+                <a:solidFill>
+                  <a:srgbClr val="FFFFFF"/>
+                </a:solidFill>
+              </a:rPr>
+              <a:t>Why Legal Connectors Matter: The Stakes of "Data Bound"</a:t>
+            </a:r>
+          </a:p>
+        </p:txBody>
+      </p:sp>
+      <p:sp>
+        <p:nvSpPr>
+          <p:cNvPr id="3" name="Rectangle 2"/>
           <p:cNvSpPr/>
           <p:nvPr/>
         </p:nvSpPr>
         <p:spPr>
           <a:xfrm>
-            <a:off x="0" y="0"/>
-            <a:ext cx="12191695" cy="109728"/>
+            <a:off x="731520" y="1417320"/>
+            <a:ext cx="10698480" cy="36576"/>
           </a:xfrm>
           <a:prstGeom prst="rect">
             <a:avLst/>
@@ -3392,14 +3275,14 @@
       </p:sp>
       <p:sp>
         <p:nvSpPr>
-          <p:cNvPr id="3" name="TextBox 2"/>
+          <p:cNvPr id="4" name="TextBox 3"/>
           <p:cNvSpPr txBox="1"/>
           <p:nvPr/>
         </p:nvSpPr>
         <p:spPr>
           <a:xfrm>
-            <a:off x="777240" y="621792"/>
-            <a:ext cx="10698480" cy="685800"/>
+            <a:off x="731520" y="1600200"/>
+            <a:ext cx="10698480" cy="960120"/>
           </a:xfrm>
           <a:prstGeom prst="rect">
             <a:avLst/>
@@ -3407,34 +3290,33 @@
           <a:noFill/>
         </p:spPr>
         <p:txBody>
-          <a:bodyPr wrap="none">
+          <a:bodyPr wrap="square">
             <a:spAutoFit/>
           </a:bodyPr>
           <a:lstStyle/>
           <a:p>
             <a:pPr algn="l"/>
             <a:r>
-              <a:rPr sz="3400" b="1">
+              <a:rPr sz="1700" b="0">
                 <a:solidFill>
                   <a:srgbClr val="FFFFFF"/>
                 </a:solidFill>
-                <a:latin typeface="Arial"/>
               </a:rPr>
-              <a:t>Why LegalTech Raises the Stakes</a:t>
-            </a:r>
-          </a:p>
-        </p:txBody>
-      </p:sp>
-      <p:sp>
-        <p:nvSpPr>
-          <p:cNvPr id="4" name="TextBox 3"/>
+              <a:t>  Legal work runs on a highly specialized technology stack: contract lifecycle management (CLM) systems, e-discovery platforms, document manag</a:t>
+            </a:r>
+          </a:p>
+        </p:txBody>
+      </p:sp>
+      <p:sp>
+        <p:nvSpPr>
+          <p:cNvPr id="5" name="TextBox 4"/>
           <p:cNvSpPr txBox="1"/>
           <p:nvPr/>
         </p:nvSpPr>
         <p:spPr>
           <a:xfrm>
-            <a:off x="960120" y="1965960"/>
-            <a:ext cx="10241280" cy="4160520"/>
+            <a:off x="731520" y="2651760"/>
+            <a:ext cx="10698480" cy="960120"/>
           </a:xfrm>
           <a:prstGeom prst="rect">
             <a:avLst/>
@@ -3447,81 +3329,28 @@
           </a:bodyPr>
           <a:lstStyle/>
           <a:p>
-            <a:pPr>
-              <a:spcAft>
-                <a:spcPts val="1300"/>
-              </a:spcAft>
-              <a:defRPr sz="2500">
-                <a:solidFill>
-                  <a:srgbClr val="D4D4D8"/>
-                </a:solidFill>
-                <a:latin typeface="Arial"/>
-              </a:defRPr>
-            </a:pPr>
-            <a:r>
-              <a:t>Legal connectors interact with sensitive case data and privileged documents</a:t>
-            </a:r>
-          </a:p>
-          <a:p>
-            <a:pPr>
-              <a:spcAft>
-                <a:spcPts val="1300"/>
-              </a:spcAft>
-              <a:defRPr sz="2300">
-                <a:solidFill>
-                  <a:srgbClr val="D4D4D8"/>
-                </a:solidFill>
-                <a:latin typeface="Arial"/>
-              </a:defRPr>
-            </a:pPr>
-            <a:r>
-              <a:t>Attorney-client privilege and jurisdictional rules supersede standard tool-use patterns</a:t>
-            </a:r>
-          </a:p>
-          <a:p>
-            <a:pPr>
-              <a:spcAft>
-                <a:spcPts val="1300"/>
-              </a:spcAft>
-              <a:defRPr sz="2300">
-                <a:solidFill>
-                  <a:srgbClr val="D4D4D8"/>
-                </a:solidFill>
-                <a:latin typeface="Arial"/>
-              </a:defRPr>
-            </a:pPr>
-            <a:r>
-              <a:t>A visual glitch may be tolerable in creative workflows; leakage in legal workflows is not</a:t>
-            </a:r>
-          </a:p>
-          <a:p>
-            <a:pPr>
-              <a:spcAft>
-                <a:spcPts val="1300"/>
-              </a:spcAft>
-              <a:defRPr sz="2500">
-                <a:solidFill>
-                  <a:srgbClr val="D4D4D8"/>
-                </a:solidFill>
-                <a:latin typeface="Arial"/>
-              </a:defRPr>
-            </a:pPr>
-            <a:r>
-              <a:t>The secure boundary must be explicit before Claude receives analysis context</a:t>
-            </a:r>
-          </a:p>
-        </p:txBody>
-      </p:sp>
-      <p:sp>
-        <p:nvSpPr>
-          <p:cNvPr id="5" name="TextBox 4"/>
+            <a:pPr algn="l"/>
+            <a:r>
+              <a:rPr sz="1700" b="0">
+                <a:solidFill>
+                  <a:srgbClr val="FFFFFF"/>
+                </a:solidFill>
+              </a:rPr>
+              <a:t>  MCP changes this paradigm. By defining tools that act as "pipes" to existing systems, Claude can query these systems in real-time without ev</a:t>
+            </a:r>
+          </a:p>
+        </p:txBody>
+      </p:sp>
+      <p:sp>
+        <p:nvSpPr>
+          <p:cNvPr id="6" name="TextBox 5"/>
           <p:cNvSpPr txBox="1"/>
           <p:nvPr/>
         </p:nvSpPr>
         <p:spPr>
           <a:xfrm>
-            <a:off x="822960" y="6263640"/>
-            <a:ext cx="6583680" cy="256032"/>
+            <a:off x="731520" y="3703320"/>
+            <a:ext cx="10698480" cy="960120"/>
           </a:xfrm>
           <a:prstGeom prst="rect">
             <a:avLst/>
@@ -3529,34 +3358,33 @@
           <a:noFill/>
         </p:spPr>
         <p:txBody>
-          <a:bodyPr wrap="none">
+          <a:bodyPr wrap="square">
             <a:spAutoFit/>
           </a:bodyPr>
           <a:lstStyle/>
           <a:p>
             <a:pPr algn="l"/>
             <a:r>
-              <a:rPr sz="1200" b="0">
-                <a:solidFill>
-                  <a:srgbClr val="A1A1AA"/>
-                </a:solidFill>
-                <a:latin typeface="Arial"/>
+              <a:rPr sz="1700" b="0">
+                <a:solidFill>
+                  <a:srgbClr val="FFFFFF"/>
+                </a:solidFill>
               </a:rPr>
-              <a:t>academy.kspl.tech | Koenig AI Academy</a:t>
-            </a:r>
-          </a:p>
-        </p:txBody>
-      </p:sp>
-      <p:sp>
-        <p:nvSpPr>
-          <p:cNvPr id="6" name="TextBox 5"/>
+              <a:t>  The Principle of Deterministic Tooling</a:t>
+            </a:r>
+          </a:p>
+        </p:txBody>
+      </p:sp>
+      <p:sp>
+        <p:nvSpPr>
+          <p:cNvPr id="7" name="TextBox 6"/>
           <p:cNvSpPr txBox="1"/>
           <p:nvPr/>
         </p:nvSpPr>
         <p:spPr>
           <a:xfrm>
-            <a:off x="10744200" y="6199632"/>
-            <a:ext cx="685800" cy="256032"/>
+            <a:off x="731520" y="4754880"/>
+            <a:ext cx="10698480" cy="960120"/>
           </a:xfrm>
           <a:prstGeom prst="rect">
             <a:avLst/>
@@ -3564,20 +3392,53 @@
           <a:noFill/>
         </p:spPr>
         <p:txBody>
-          <a:bodyPr wrap="none">
+          <a:bodyPr wrap="square">
             <a:spAutoFit/>
           </a:bodyPr>
           <a:lstStyle/>
           <a:p>
-            <a:pPr algn="r"/>
-            <a:r>
-              <a:rPr sz="1200" b="0">
+            <a:pPr algn="l"/>
+            <a:r>
+              <a:rPr sz="1700" b="0">
+                <a:solidFill>
+                  <a:srgbClr val="FFFFFF"/>
+                </a:solidFill>
+              </a:rPr>
+              <a:t>  In legal contexts, tools must behave deterministically. If a lawyer asks Claude to "Redact this document," they aren't looking for a "best e</a:t>
+            </a:r>
+          </a:p>
+        </p:txBody>
+      </p:sp>
+      <p:sp>
+        <p:nvSpPr>
+          <p:cNvPr id="8" name="TextBox 7"/>
+          <p:cNvSpPr txBox="1"/>
+          <p:nvPr/>
+        </p:nvSpPr>
+        <p:spPr>
+          <a:xfrm>
+            <a:off x="731520" y="6263640"/>
+            <a:ext cx="10698480" cy="365760"/>
+          </a:xfrm>
+          <a:prstGeom prst="rect">
+            <a:avLst/>
+          </a:prstGeom>
+          <a:noFill/>
+        </p:spPr>
+        <p:txBody>
+          <a:bodyPr wrap="square">
+            <a:spAutoFit/>
+          </a:bodyPr>
+          <a:lstStyle/>
+          <a:p>
+            <a:pPr algn="l"/>
+            <a:r>
+              <a:rPr sz="1000" b="0">
                 <a:solidFill>
                   <a:srgbClr val="A1A1AA"/>
                 </a:solidFill>
-                <a:latin typeface="Arial"/>
               </a:rPr>
-              <a:t>2/7</a:t>
+              <a:t>academy.kspl.tech | Koenig AI Academy</a:t>
             </a:r>
           </a:p>
         </p:txBody>
@@ -3610,14 +3471,48 @@
       <p:grpSpPr/>
       <p:sp>
         <p:nvSpPr>
-          <p:cNvPr id="2" name="Rectangle 1"/>
+          <p:cNvPr id="2" name="TextBox 1"/>
+          <p:cNvSpPr txBox="1"/>
+          <p:nvPr/>
+        </p:nvSpPr>
+        <p:spPr>
+          <a:xfrm>
+            <a:off x="731520" y="411480"/>
+            <a:ext cx="10698480" cy="1005840"/>
+          </a:xfrm>
+          <a:prstGeom prst="rect">
+            <a:avLst/>
+          </a:prstGeom>
+          <a:noFill/>
+        </p:spPr>
+        <p:txBody>
+          <a:bodyPr wrap="square">
+            <a:spAutoFit/>
+          </a:bodyPr>
+          <a:lstStyle/>
+          <a:p>
+            <a:pPr algn="l"/>
+            <a:r>
+              <a:rPr sz="2800" b="1">
+                <a:solidFill>
+                  <a:srgbClr val="FFFFFF"/>
+                </a:solidFill>
+              </a:rPr>
+              <a:t>The May 2026 Connector Inventory</a:t>
+            </a:r>
+          </a:p>
+        </p:txBody>
+      </p:sp>
+      <p:sp>
+        <p:nvSpPr>
+          <p:cNvPr id="3" name="Rectangle 2"/>
           <p:cNvSpPr/>
           <p:nvPr/>
         </p:nvSpPr>
         <p:spPr>
           <a:xfrm>
-            <a:off x="0" y="0"/>
-            <a:ext cx="12191695" cy="109728"/>
+            <a:off x="731520" y="1417320"/>
+            <a:ext cx="10698480" cy="36576"/>
           </a:xfrm>
           <a:prstGeom prst="rect">
             <a:avLst/>
@@ -3653,14 +3548,14 @@
       </p:sp>
       <p:sp>
         <p:nvSpPr>
-          <p:cNvPr id="3" name="TextBox 2"/>
+          <p:cNvPr id="4" name="TextBox 3"/>
           <p:cNvSpPr txBox="1"/>
           <p:nvPr/>
         </p:nvSpPr>
         <p:spPr>
           <a:xfrm>
-            <a:off x="777240" y="621792"/>
-            <a:ext cx="10698480" cy="685800"/>
+            <a:off x="731520" y="1600200"/>
+            <a:ext cx="10698480" cy="960120"/>
           </a:xfrm>
           <a:prstGeom prst="rect">
             <a:avLst/>
@@ -3668,34 +3563,33 @@
           <a:noFill/>
         </p:spPr>
         <p:txBody>
-          <a:bodyPr wrap="none">
+          <a:bodyPr wrap="square">
             <a:spAutoFit/>
           </a:bodyPr>
           <a:lstStyle/>
           <a:p>
             <a:pPr algn="l"/>
             <a:r>
-              <a:rPr sz="3400" b="1">
+              <a:rPr sz="1700" b="0">
                 <a:solidFill>
                   <a:srgbClr val="FFFFFF"/>
                 </a:solidFill>
-                <a:latin typeface="Arial"/>
               </a:rPr>
-              <a:t>Regulatory Requirements</a:t>
-            </a:r>
-          </a:p>
-        </p:txBody>
-      </p:sp>
-      <p:sp>
-        <p:nvSpPr>
-          <p:cNvPr id="4" name="TextBox 3"/>
+              <a:t>  The expansion of the MCP ecosystem in May 2026 targeted virtually every segment of the legal market. Understanding this inventory is crucial</a:t>
+            </a:r>
+          </a:p>
+        </p:txBody>
+      </p:sp>
+      <p:sp>
+        <p:nvSpPr>
+          <p:cNvPr id="5" name="TextBox 4"/>
           <p:cNvSpPr txBox="1"/>
           <p:nvPr/>
         </p:nvSpPr>
         <p:spPr>
           <a:xfrm>
-            <a:off x="960120" y="1965960"/>
-            <a:ext cx="10241280" cy="4160520"/>
+            <a:off x="731520" y="2651760"/>
+            <a:ext cx="10698480" cy="960120"/>
           </a:xfrm>
           <a:prstGeom prst="rect">
             <a:avLst/>
@@ -3708,81 +3602,28 @@
           </a:bodyPr>
           <a:lstStyle/>
           <a:p>
-            <a:pPr>
-              <a:spcAft>
-                <a:spcPts val="1300"/>
-              </a:spcAft>
-              <a:defRPr sz="2500">
-                <a:solidFill>
-                  <a:srgbClr val="D4D4D8"/>
-                </a:solidFill>
-                <a:latin typeface="Arial"/>
-              </a:defRPr>
-            </a:pPr>
-            <a:r>
-              <a:t>Confidentiality: redact PII before it leaves the local secure environment</a:t>
-            </a:r>
-          </a:p>
-          <a:p>
-            <a:pPr>
-              <a:spcAft>
-                <a:spcPts val="1300"/>
-              </a:spcAft>
-              <a:defRPr sz="2500">
-                <a:solidFill>
-                  <a:srgbClr val="D4D4D8"/>
-                </a:solidFill>
-                <a:latin typeface="Arial"/>
-              </a:defRPr>
-            </a:pPr>
-            <a:r>
-              <a:t>Audit trails: log every tool call in read-only, tamper-proof form</a:t>
-            </a:r>
-          </a:p>
-          <a:p>
-            <a:pPr>
-              <a:spcAft>
-                <a:spcPts val="1300"/>
-              </a:spcAft>
-              <a:defRPr sz="2500">
-                <a:solidFill>
-                  <a:srgbClr val="D4D4D8"/>
-                </a:solidFill>
-                <a:latin typeface="Arial"/>
-              </a:defRPr>
-            </a:pPr>
-            <a:r>
-              <a:t>Data residency: deploy MCP server infrastructure inside the required jurisdiction</a:t>
-            </a:r>
-          </a:p>
-          <a:p>
-            <a:pPr>
-              <a:spcAft>
-                <a:spcPts val="1300"/>
-              </a:spcAft>
-              <a:defRPr sz="2500">
-                <a:solidFill>
-                  <a:srgbClr val="D4D4D8"/>
-                </a:solidFill>
-                <a:latin typeface="Arial"/>
-              </a:defRPr>
-            </a:pPr>
-            <a:r>
-              <a:t>Audit logs should record access events, not raw document contents</a:t>
-            </a:r>
-          </a:p>
-        </p:txBody>
-      </p:sp>
-      <p:sp>
-        <p:nvSpPr>
-          <p:cNvPr id="5" name="TextBox 4"/>
+            <a:pPr algn="l"/>
+            <a:r>
+              <a:rPr sz="1700" b="0">
+                <a:solidFill>
+                  <a:srgbClr val="FFFFFF"/>
+                </a:solidFill>
+              </a:rPr>
+              <a:t>  1. Contract Lifecycle and Drafting</a:t>
+            </a:r>
+          </a:p>
+        </p:txBody>
+      </p:sp>
+      <p:sp>
+        <p:nvSpPr>
+          <p:cNvPr id="6" name="TextBox 5"/>
           <p:cNvSpPr txBox="1"/>
           <p:nvPr/>
         </p:nvSpPr>
         <p:spPr>
           <a:xfrm>
-            <a:off x="822960" y="6263640"/>
-            <a:ext cx="6583680" cy="256032"/>
+            <a:off x="731520" y="3703320"/>
+            <a:ext cx="10698480" cy="960120"/>
           </a:xfrm>
           <a:prstGeom prst="rect">
             <a:avLst/>
@@ -3790,34 +3631,33 @@
           <a:noFill/>
         </p:spPr>
         <p:txBody>
-          <a:bodyPr wrap="none">
+          <a:bodyPr wrap="square">
             <a:spAutoFit/>
           </a:bodyPr>
           <a:lstStyle/>
           <a:p>
             <a:pPr algn="l"/>
             <a:r>
-              <a:rPr sz="1200" b="0">
-                <a:solidFill>
-                  <a:srgbClr val="A1A1AA"/>
-                </a:solidFill>
-                <a:latin typeface="Arial"/>
+              <a:rPr sz="1700" b="0">
+                <a:solidFill>
+                  <a:srgbClr val="FFFFFF"/>
+                </a:solidFill>
               </a:rPr>
-              <a:t>academy.kspl.tech | Koenig AI Academy</a:t>
-            </a:r>
-          </a:p>
-        </p:txBody>
-      </p:sp>
-      <p:sp>
-        <p:nvSpPr>
-          <p:cNvPr id="6" name="TextBox 5"/>
+              <a:t>  These connectors manage the lifecycle of an agreement, from initial drafting and negotiation to signature and post-execution auditing.</a:t>
+            </a:r>
+          </a:p>
+        </p:txBody>
+      </p:sp>
+      <p:sp>
+        <p:nvSpPr>
+          <p:cNvPr id="7" name="TextBox 6"/>
           <p:cNvSpPr txBox="1"/>
           <p:nvPr/>
         </p:nvSpPr>
         <p:spPr>
           <a:xfrm>
-            <a:off x="10744200" y="6199632"/>
-            <a:ext cx="685800" cy="256032"/>
+            <a:off x="731520" y="4754880"/>
+            <a:ext cx="10698480" cy="960120"/>
           </a:xfrm>
           <a:prstGeom prst="rect">
             <a:avLst/>
@@ -3825,34 +3665,33 @@
           <a:noFill/>
         </p:spPr>
         <p:txBody>
-          <a:bodyPr wrap="none">
+          <a:bodyPr wrap="square">
             <a:spAutoFit/>
           </a:bodyPr>
           <a:lstStyle/>
           <a:p>
-            <a:pPr algn="r"/>
-            <a:r>
-              <a:rPr sz="1200" b="0">
-                <a:solidFill>
-                  <a:srgbClr val="A1A1AA"/>
-                </a:solidFill>
-                <a:latin typeface="Arial"/>
+            <a:pPr algn="l"/>
+            <a:r>
+              <a:rPr sz="1700" b="0">
+                <a:solidFill>
+                  <a:srgbClr val="FFFFFF"/>
+                </a:solidFill>
               </a:rPr>
-              <a:t>3/7</a:t>
-            </a:r>
-          </a:p>
-        </p:txBody>
-      </p:sp>
-      <p:sp>
-        <p:nvSpPr>
-          <p:cNvPr id="7" name="TextBox 6"/>
+              <a:t>  Definely gives Claude deterministic access to contract structure: definitions, cross-references, dependency maps, and structural diffs [3].</a:t>
+            </a:r>
+          </a:p>
+        </p:txBody>
+      </p:sp>
+      <p:sp>
+        <p:nvSpPr>
+          <p:cNvPr id="8" name="TextBox 7"/>
           <p:cNvSpPr txBox="1"/>
           <p:nvPr/>
         </p:nvSpPr>
         <p:spPr>
           <a:xfrm>
-            <a:off x="960120" y="5440680"/>
-            <a:ext cx="10058400" cy="320040"/>
+            <a:off x="731520" y="6263640"/>
+            <a:ext cx="10698480" cy="365760"/>
           </a:xfrm>
           <a:prstGeom prst="rect">
             <a:avLst/>
@@ -3860,20 +3699,19 @@
           <a:noFill/>
         </p:spPr>
         <p:txBody>
-          <a:bodyPr wrap="none">
+          <a:bodyPr wrap="square">
             <a:spAutoFit/>
           </a:bodyPr>
           <a:lstStyle/>
           <a:p>
             <a:pPr algn="l"/>
             <a:r>
-              <a:rPr sz="1500" b="1">
-                <a:solidFill>
-                  <a:srgbClr val="FACC15"/>
-                </a:solidFill>
-                <a:latin typeface="Arial"/>
+              <a:rPr sz="1000" b="0">
+                <a:solidFill>
+                  <a:srgbClr val="A1A1AA"/>
+                </a:solidFill>
               </a:rPr>
-              <a:t>Never log raw PII: record that a file was accessed, not its contents.</a:t>
+              <a:t>academy.kspl.tech | Koenig AI Academy</a:t>
             </a:r>
           </a:p>
         </p:txBody>
@@ -3906,14 +3744,48 @@
       <p:grpSpPr/>
       <p:sp>
         <p:nvSpPr>
-          <p:cNvPr id="2" name="Rectangle 1"/>
+          <p:cNvPr id="2" name="TextBox 1"/>
+          <p:cNvSpPr txBox="1"/>
+          <p:nvPr/>
+        </p:nvSpPr>
+        <p:spPr>
+          <a:xfrm>
+            <a:off x="731520" y="411480"/>
+            <a:ext cx="10698480" cy="1005840"/>
+          </a:xfrm>
+          <a:prstGeom prst="rect">
+            <a:avLst/>
+          </a:prstGeom>
+          <a:noFill/>
+        </p:spPr>
+        <p:txBody>
+          <a:bodyPr wrap="square">
+            <a:spAutoFit/>
+          </a:bodyPr>
+          <a:lstStyle/>
+          <a:p>
+            <a:pPr algn="l"/>
+            <a:r>
+              <a:rPr sz="2800" b="1">
+                <a:solidFill>
+                  <a:srgbClr val="FFFFFF"/>
+                </a:solidFill>
+              </a:rPr>
+              <a:t>Practice-Area Plugins: Intelligence vs. Infrastructure</a:t>
+            </a:r>
+          </a:p>
+        </p:txBody>
+      </p:sp>
+      <p:sp>
+        <p:nvSpPr>
+          <p:cNvPr id="3" name="Rectangle 2"/>
           <p:cNvSpPr/>
           <p:nvPr/>
         </p:nvSpPr>
         <p:spPr>
           <a:xfrm>
-            <a:off x="0" y="0"/>
-            <a:ext cx="12191695" cy="109728"/>
+            <a:off x="731520" y="1417320"/>
+            <a:ext cx="10698480" cy="36576"/>
           </a:xfrm>
           <a:prstGeom prst="rect">
             <a:avLst/>
@@ -3949,14 +3821,14 @@
       </p:sp>
       <p:sp>
         <p:nvSpPr>
-          <p:cNvPr id="3" name="TextBox 2"/>
+          <p:cNvPr id="4" name="TextBox 3"/>
           <p:cNvSpPr txBox="1"/>
           <p:nvPr/>
         </p:nvSpPr>
         <p:spPr>
           <a:xfrm>
-            <a:off x="777240" y="621792"/>
-            <a:ext cx="10698480" cy="685800"/>
+            <a:off x="731520" y="1600200"/>
+            <a:ext cx="10698480" cy="960120"/>
           </a:xfrm>
           <a:prstGeom prst="rect">
             <a:avLst/>
@@ -3964,34 +3836,33 @@
           <a:noFill/>
         </p:spPr>
         <p:txBody>
-          <a:bodyPr wrap="none">
+          <a:bodyPr wrap="square">
             <a:spAutoFit/>
           </a:bodyPr>
           <a:lstStyle/>
           <a:p>
             <a:pPr algn="l"/>
             <a:r>
-              <a:rPr sz="3400" b="1">
+              <a:rPr sz="1700" b="0">
                 <a:solidFill>
                   <a:srgbClr val="FFFFFF"/>
                 </a:solidFill>
-                <a:latin typeface="Arial"/>
               </a:rPr>
-              <a:t>Compliance-First Tool Definitions</a:t>
-            </a:r>
-          </a:p>
-        </p:txBody>
-      </p:sp>
-      <p:sp>
-        <p:nvSpPr>
-          <p:cNvPr id="4" name="TextBox 3"/>
+              <a:t>  There is a critical distinction in the Anthropic ecosystem between an MCP Connector and a Practice-Area Plugin:</a:t>
+            </a:r>
+          </a:p>
+        </p:txBody>
+      </p:sp>
+      <p:sp>
+        <p:nvSpPr>
+          <p:cNvPr id="5" name="TextBox 4"/>
           <p:cNvSpPr txBox="1"/>
           <p:nvPr/>
         </p:nvSpPr>
         <p:spPr>
           <a:xfrm>
-            <a:off x="960120" y="1965960"/>
-            <a:ext cx="10241280" cy="4160520"/>
+            <a:off x="731520" y="2651760"/>
+            <a:ext cx="10698480" cy="960120"/>
           </a:xfrm>
           <a:prstGeom prst="rect">
             <a:avLst/>
@@ -4004,81 +3875,28 @@
           </a:bodyPr>
           <a:lstStyle/>
           <a:p>
-            <a:pPr>
-              <a:spcAft>
-                <a:spcPts val="1300"/>
-              </a:spcAft>
-              <a:defRPr sz="2500">
-                <a:solidFill>
-                  <a:srgbClr val="D4D4D8"/>
-                </a:solidFill>
-                <a:latin typeface="Arial"/>
-              </a:defRPr>
-            </a:pPr>
-            <a:r>
-              <a:t>Tool descriptions must state data bounds and local execution requirements</a:t>
-            </a:r>
-          </a:p>
-          <a:p>
-            <a:pPr>
-              <a:spcAft>
-                <a:spcPts val="1300"/>
-              </a:spcAft>
-              <a:defRPr sz="2500">
-                <a:solidFill>
-                  <a:srgbClr val="D4D4D8"/>
-                </a:solidFill>
-                <a:latin typeface="Arial"/>
-              </a:defRPr>
-            </a:pPr>
-            <a:r>
-              <a:t>Redaction tools should behave deterministically rather than creatively</a:t>
-            </a:r>
-          </a:p>
-          <a:p>
-            <a:pPr>
-              <a:spcAft>
-                <a:spcPts val="1300"/>
-              </a:spcAft>
-              <a:defRPr sz="2500">
-                <a:solidFill>
-                  <a:srgbClr val="D4D4D8"/>
-                </a:solidFill>
-                <a:latin typeface="Arial"/>
-              </a:defRPr>
-            </a:pPr>
-            <a:r>
-              <a:t>Access tools need fine-grained authorization around document paths and PII types</a:t>
-            </a:r>
-          </a:p>
-          <a:p>
-            <a:pPr>
-              <a:spcAft>
-                <a:spcPts val="1300"/>
-              </a:spcAft>
-              <a:defRPr sz="2500">
-                <a:solidFill>
-                  <a:srgbClr val="D4D4D8"/>
-                </a:solidFill>
-                <a:latin typeface="Arial"/>
-              </a:defRPr>
-            </a:pPr>
-            <a:r>
-              <a:t>Input schemas should make required fields and permitted PII categories explicit</a:t>
-            </a:r>
-          </a:p>
-        </p:txBody>
-      </p:sp>
-      <p:sp>
-        <p:nvSpPr>
-          <p:cNvPr id="5" name="TextBox 4"/>
+            <a:pPr algn="l"/>
+            <a:r>
+              <a:rPr sz="1700" b="0">
+                <a:solidFill>
+                  <a:srgbClr val="FFFFFF"/>
+                </a:solidFill>
+              </a:rPr>
+              <a:t>  Connector: The technical bridge to a specific platform, data source, or external capability, such as iManage, Everlaw, Ironclad, TopCounsel,</a:t>
+            </a:r>
+          </a:p>
+        </p:txBody>
+      </p:sp>
+      <p:sp>
+        <p:nvSpPr>
+          <p:cNvPr id="6" name="TextBox 5"/>
           <p:cNvSpPr txBox="1"/>
           <p:nvPr/>
         </p:nvSpPr>
         <p:spPr>
           <a:xfrm>
-            <a:off x="822960" y="6263640"/>
-            <a:ext cx="6583680" cy="256032"/>
+            <a:off x="731520" y="3703320"/>
+            <a:ext cx="10698480" cy="960120"/>
           </a:xfrm>
           <a:prstGeom prst="rect">
             <a:avLst/>
@@ -4086,34 +3904,33 @@
           <a:noFill/>
         </p:spPr>
         <p:txBody>
-          <a:bodyPr wrap="none">
+          <a:bodyPr wrap="square">
             <a:spAutoFit/>
           </a:bodyPr>
           <a:lstStyle/>
           <a:p>
             <a:pPr algn="l"/>
             <a:r>
-              <a:rPr sz="1200" b="0">
-                <a:solidFill>
-                  <a:srgbClr val="A1A1AA"/>
-                </a:solidFill>
-                <a:latin typeface="Arial"/>
+              <a:rPr sz="1700" b="0">
+                <a:solidFill>
+                  <a:srgbClr val="FFFFFF"/>
+                </a:solidFill>
               </a:rPr>
-              <a:t>academy.kspl.tech | Koenig AI Academy</a:t>
-            </a:r>
-          </a:p>
-        </p:txBody>
-      </p:sp>
-      <p:sp>
-        <p:nvSpPr>
-          <p:cNvPr id="6" name="TextBox 5"/>
+              <a:t>  Plugin: The domain-specific workflow package: prompts, slash commands, skills, guardrails, and what Anthropic calls "Setup Interviews" [3][4</a:t>
+            </a:r>
+          </a:p>
+        </p:txBody>
+      </p:sp>
+      <p:sp>
+        <p:nvSpPr>
+          <p:cNvPr id="7" name="TextBox 6"/>
           <p:cNvSpPr txBox="1"/>
           <p:nvPr/>
         </p:nvSpPr>
         <p:spPr>
           <a:xfrm>
-            <a:off x="10744200" y="6199632"/>
-            <a:ext cx="685800" cy="256032"/>
+            <a:off x="731520" y="4754880"/>
+            <a:ext cx="10698480" cy="960120"/>
           </a:xfrm>
           <a:prstGeom prst="rect">
             <a:avLst/>
@@ -4121,20 +3938,53 @@
           <a:noFill/>
         </p:spPr>
         <p:txBody>
-          <a:bodyPr wrap="none">
+          <a:bodyPr wrap="square">
             <a:spAutoFit/>
           </a:bodyPr>
           <a:lstStyle/>
           <a:p>
-            <a:pPr algn="r"/>
-            <a:r>
-              <a:rPr sz="1200" b="0">
+            <a:pPr algn="l"/>
+            <a:r>
+              <a:rPr sz="1700" b="0">
+                <a:solidFill>
+                  <a:srgbClr val="FFFFFF"/>
+                </a:solidFill>
+              </a:rPr>
+              <a:t>  The "Setup Interview" Pattern</a:t>
+            </a:r>
+          </a:p>
+        </p:txBody>
+      </p:sp>
+      <p:sp>
+        <p:nvSpPr>
+          <p:cNvPr id="8" name="TextBox 7"/>
+          <p:cNvSpPr txBox="1"/>
+          <p:nvPr/>
+        </p:nvSpPr>
+        <p:spPr>
+          <a:xfrm>
+            <a:off x="731520" y="6263640"/>
+            <a:ext cx="10698480" cy="365760"/>
+          </a:xfrm>
+          <a:prstGeom prst="rect">
+            <a:avLst/>
+          </a:prstGeom>
+          <a:noFill/>
+        </p:spPr>
+        <p:txBody>
+          <a:bodyPr wrap="square">
+            <a:spAutoFit/>
+          </a:bodyPr>
+          <a:lstStyle/>
+          <a:p>
+            <a:pPr algn="l"/>
+            <a:r>
+              <a:rPr sz="1000" b="0">
                 <a:solidFill>
                   <a:srgbClr val="A1A1AA"/>
                 </a:solidFill>
-                <a:latin typeface="Arial"/>
               </a:rPr>
-              <a:t>4/7</a:t>
+              <a:t>academy.kspl.tech | Koenig AI Academy</a:t>
             </a:r>
           </a:p>
         </p:txBody>
@@ -4167,14 +4017,48 @@
       <p:grpSpPr/>
       <p:sp>
         <p:nvSpPr>
-          <p:cNvPr id="2" name="Rectangle 1"/>
+          <p:cNvPr id="2" name="TextBox 1"/>
+          <p:cNvSpPr txBox="1"/>
+          <p:nvPr/>
+        </p:nvSpPr>
+        <p:spPr>
+          <a:xfrm>
+            <a:off x="731520" y="411480"/>
+            <a:ext cx="10698480" cy="1005840"/>
+          </a:xfrm>
+          <a:prstGeom prst="rect">
+            <a:avLst/>
+          </a:prstGeom>
+          <a:noFill/>
+        </p:spPr>
+        <p:txBody>
+          <a:bodyPr wrap="square">
+            <a:spAutoFit/>
+          </a:bodyPr>
+          <a:lstStyle/>
+          <a:p>
+            <a:pPr algn="l"/>
+            <a:r>
+              <a:rPr sz="2800" b="1">
+                <a:solidFill>
+                  <a:srgbClr val="FFFFFF"/>
+                </a:solidFill>
+              </a:rPr>
+              <a:t>Designing Compliance-First Tool Definitions</a:t>
+            </a:r>
+          </a:p>
+        </p:txBody>
+      </p:sp>
+      <p:sp>
+        <p:nvSpPr>
+          <p:cNvPr id="3" name="Rectangle 2"/>
           <p:cNvSpPr/>
           <p:nvPr/>
         </p:nvSpPr>
         <p:spPr>
           <a:xfrm>
-            <a:off x="0" y="0"/>
-            <a:ext cx="12191695" cy="109728"/>
+            <a:off x="731520" y="1417320"/>
+            <a:ext cx="10698480" cy="36576"/>
           </a:xfrm>
           <a:prstGeom prst="rect">
             <a:avLst/>
@@ -4210,14 +4094,14 @@
       </p:sp>
       <p:sp>
         <p:nvSpPr>
-          <p:cNvPr id="3" name="TextBox 2"/>
+          <p:cNvPr id="4" name="TextBox 3"/>
           <p:cNvSpPr txBox="1"/>
           <p:nvPr/>
         </p:nvSpPr>
         <p:spPr>
           <a:xfrm>
-            <a:off x="777240" y="621792"/>
-            <a:ext cx="10698480" cy="685800"/>
+            <a:off x="731520" y="1600200"/>
+            <a:ext cx="10698480" cy="960120"/>
           </a:xfrm>
           <a:prstGeom prst="rect">
             <a:avLst/>
@@ -4225,34 +4109,33 @@
           <a:noFill/>
         </p:spPr>
         <p:txBody>
-          <a:bodyPr wrap="none">
+          <a:bodyPr wrap="square">
             <a:spAutoFit/>
           </a:bodyPr>
           <a:lstStyle/>
           <a:p>
             <a:pPr algn="l"/>
             <a:r>
-              <a:rPr sz="3400" b="1">
+              <a:rPr sz="1700" b="0">
                 <a:solidFill>
                   <a:srgbClr val="FFFFFF"/>
                 </a:solidFill>
-                <a:latin typeface="Arial"/>
               </a:rPr>
-              <a:t>Secure Redaction Walkthrough</a:t>
-            </a:r>
-          </a:p>
-        </p:txBody>
-      </p:sp>
-      <p:sp>
-        <p:nvSpPr>
-          <p:cNvPr id="4" name="TextBox 3"/>
+              <a:t>  When you are tasked with building a custom MCP connector for a legal team, your tool definitions must prioritize data boundary enforcement.</a:t>
+            </a:r>
+          </a:p>
+        </p:txBody>
+      </p:sp>
+      <p:sp>
+        <p:nvSpPr>
+          <p:cNvPr id="5" name="TextBox 4"/>
           <p:cNvSpPr txBox="1"/>
           <p:nvPr/>
         </p:nvSpPr>
         <p:spPr>
           <a:xfrm>
-            <a:off x="960120" y="1965960"/>
-            <a:ext cx="10241280" cy="4160520"/>
+            <a:off x="731520" y="2651760"/>
+            <a:ext cx="10698480" cy="960120"/>
           </a:xfrm>
           <a:prstGeom prst="rect">
             <a:avLst/>
@@ -4265,81 +4148,28 @@
           </a:bodyPr>
           <a:lstStyle/>
           <a:p>
-            <a:pPr>
-              <a:spcAft>
-                <a:spcPts val="1300"/>
-              </a:spcAft>
-              <a:defRPr sz="2500">
-                <a:solidFill>
-                  <a:srgbClr val="D4D4D8"/>
-                </a:solidFill>
-                <a:latin typeface="Arial"/>
-              </a:defRPr>
-            </a:pPr>
-            <a:r>
-              <a:t>Start with an access-intent audit entry before touching the document</a:t>
-            </a:r>
-          </a:p>
-          <a:p>
-            <a:pPr>
-              <a:spcAft>
-                <a:spcPts val="1300"/>
-              </a:spcAft>
-              <a:defRPr sz="2500">
-                <a:solidFill>
-                  <a:srgbClr val="D4D4D8"/>
-                </a:solidFill>
-                <a:latin typeface="Arial"/>
-              </a:defRPr>
-            </a:pPr>
-            <a:r>
-              <a:t>Run redaction locally and return a redacted document path</a:t>
-            </a:r>
-          </a:p>
-          <a:p>
-            <a:pPr>
-              <a:spcAft>
-                <a:spcPts val="1300"/>
-              </a:spcAft>
-              <a:defRPr sz="2500">
-                <a:solidFill>
-                  <a:srgbClr val="D4D4D8"/>
-                </a:solidFill>
-                <a:latin typeface="Arial"/>
-              </a:defRPr>
-            </a:pPr>
-            <a:r>
-              <a:t>Avoid logging raw PII even when the audit log is secure</a:t>
-            </a:r>
-          </a:p>
-          <a:p>
-            <a:pPr>
-              <a:spcAft>
-                <a:spcPts val="1300"/>
-              </a:spcAft>
-              <a:defRPr sz="2500">
-                <a:solidFill>
-                  <a:srgbClr val="D4D4D8"/>
-                </a:solidFill>
-                <a:latin typeface="Arial"/>
-              </a:defRPr>
-            </a:pPr>
-            <a:r>
-              <a:t>Verify the file output before and after the redaction service runs</a:t>
-            </a:r>
-          </a:p>
-        </p:txBody>
-      </p:sp>
-      <p:sp>
-        <p:nvSpPr>
-          <p:cNvPr id="5" name="TextBox 4"/>
+            <a:pPr algn="l"/>
+            <a:r>
+              <a:rPr sz="1700" b="0">
+                <a:solidFill>
+                  <a:srgbClr val="FFFFFF"/>
+                </a:solidFill>
+              </a:rPr>
+              <a:t>  Implementation: The Redaction Tool</a:t>
+            </a:r>
+          </a:p>
+        </p:txBody>
+      </p:sp>
+      <p:sp>
+        <p:nvSpPr>
+          <p:cNvPr id="6" name="TextBox 5"/>
           <p:cNvSpPr txBox="1"/>
           <p:nvPr/>
         </p:nvSpPr>
         <p:spPr>
           <a:xfrm>
-            <a:off x="822960" y="6263640"/>
-            <a:ext cx="6583680" cy="256032"/>
+            <a:off x="731520" y="3703320"/>
+            <a:ext cx="10698480" cy="960120"/>
           </a:xfrm>
           <a:prstGeom prst="rect">
             <a:avLst/>
@@ -4347,34 +4177,33 @@
           <a:noFill/>
         </p:spPr>
         <p:txBody>
-          <a:bodyPr wrap="none">
+          <a:bodyPr wrap="square">
             <a:spAutoFit/>
           </a:bodyPr>
           <a:lstStyle/>
           <a:p>
             <a:pPr algn="l"/>
             <a:r>
-              <a:rPr sz="1200" b="0">
-                <a:solidFill>
-                  <a:srgbClr val="A1A1AA"/>
-                </a:solidFill>
-                <a:latin typeface="Arial"/>
+              <a:rPr sz="1700" b="0">
+                <a:solidFill>
+                  <a:srgbClr val="FFFFFF"/>
+                </a:solidFill>
               </a:rPr>
-              <a:t>academy.kspl.tech | Koenig AI Academy</a:t>
-            </a:r>
-          </a:p>
-        </p:txBody>
-      </p:sp>
-      <p:sp>
-        <p:nvSpPr>
-          <p:cNvPr id="6" name="TextBox 5"/>
+              <a:t>  A core requirement in legal workflows is to ensure PII (Personally Identifiable Information) never leaves the local environment. A redaction</a:t>
+            </a:r>
+          </a:p>
+        </p:txBody>
+      </p:sp>
+      <p:sp>
+        <p:nvSpPr>
+          <p:cNvPr id="7" name="TextBox 6"/>
           <p:cNvSpPr txBox="1"/>
           <p:nvPr/>
         </p:nvSpPr>
         <p:spPr>
           <a:xfrm>
-            <a:off x="10744200" y="6199632"/>
-            <a:ext cx="685800" cy="256032"/>
+            <a:off x="731520" y="4754880"/>
+            <a:ext cx="10698480" cy="960120"/>
           </a:xfrm>
           <a:prstGeom prst="rect">
             <a:avLst/>
@@ -4382,20 +4211,53 @@
           <a:noFill/>
         </p:spPr>
         <p:txBody>
-          <a:bodyPr wrap="none">
+          <a:bodyPr wrap="square">
             <a:spAutoFit/>
           </a:bodyPr>
           <a:lstStyle/>
           <a:p>
-            <a:pPr algn="r"/>
-            <a:r>
-              <a:rPr sz="1200" b="0">
+            <a:pPr algn="l"/>
+            <a:r>
+              <a:rPr sz="1700" b="0">
+                <a:solidFill>
+                  <a:srgbClr val="FFFFFF"/>
+                </a:solidFill>
+              </a:rPr>
+              <a:t>  model="claude-sonnet-4-6"</a:t>
+            </a:r>
+          </a:p>
+        </p:txBody>
+      </p:sp>
+      <p:sp>
+        <p:nvSpPr>
+          <p:cNvPr id="8" name="TextBox 7"/>
+          <p:cNvSpPr txBox="1"/>
+          <p:nvPr/>
+        </p:nvSpPr>
+        <p:spPr>
+          <a:xfrm>
+            <a:off x="731520" y="6263640"/>
+            <a:ext cx="10698480" cy="365760"/>
+          </a:xfrm>
+          <a:prstGeom prst="rect">
+            <a:avLst/>
+          </a:prstGeom>
+          <a:noFill/>
+        </p:spPr>
+        <p:txBody>
+          <a:bodyPr wrap="square">
+            <a:spAutoFit/>
+          </a:bodyPr>
+          <a:lstStyle/>
+          <a:p>
+            <a:pPr algn="l"/>
+            <a:r>
+              <a:rPr sz="1000" b="0">
                 <a:solidFill>
                   <a:srgbClr val="A1A1AA"/>
                 </a:solidFill>
-                <a:latin typeface="Arial"/>
               </a:rPr>
-              <a:t>5/7</a:t>
+              <a:t>academy.kspl.tech | Koenig AI Academy</a:t>
             </a:r>
           </a:p>
         </p:txBody>
@@ -4428,14 +4290,48 @@
       <p:grpSpPr/>
       <p:sp>
         <p:nvSpPr>
-          <p:cNvPr id="2" name="Rectangle 1"/>
+          <p:cNvPr id="2" name="TextBox 1"/>
+          <p:cNvSpPr txBox="1"/>
+          <p:nvPr/>
+        </p:nvSpPr>
+        <p:spPr>
+          <a:xfrm>
+            <a:off x="731520" y="411480"/>
+            <a:ext cx="10698480" cy="1005840"/>
+          </a:xfrm>
+          <a:prstGeom prst="rect">
+            <a:avLst/>
+          </a:prstGeom>
+          <a:noFill/>
+        </p:spPr>
+        <p:txBody>
+          <a:bodyPr wrap="square">
+            <a:spAutoFit/>
+          </a:bodyPr>
+          <a:lstStyle/>
+          <a:p>
+            <a:pPr algn="l"/>
+            <a:r>
+              <a:rPr sz="2800" b="1">
+                <a:solidFill>
+                  <a:srgbClr val="FFFFFF"/>
+                </a:solidFill>
+              </a:rPr>
+              <a:t>Implementation Walkthrough: E-Discovery Search</a:t>
+            </a:r>
+          </a:p>
+        </p:txBody>
+      </p:sp>
+      <p:sp>
+        <p:nvSpPr>
+          <p:cNvPr id="3" name="Rectangle 2"/>
           <p:cNvSpPr/>
           <p:nvPr/>
         </p:nvSpPr>
         <p:spPr>
           <a:xfrm>
-            <a:off x="0" y="0"/>
-            <a:ext cx="12191695" cy="109728"/>
+            <a:off x="731520" y="1417320"/>
+            <a:ext cx="10698480" cy="36576"/>
           </a:xfrm>
           <a:prstGeom prst="rect">
             <a:avLst/>
@@ -4471,14 +4367,14 @@
       </p:sp>
       <p:sp>
         <p:nvSpPr>
-          <p:cNvPr id="3" name="TextBox 2"/>
+          <p:cNvPr id="4" name="TextBox 3"/>
           <p:cNvSpPr txBox="1"/>
           <p:nvPr/>
         </p:nvSpPr>
         <p:spPr>
           <a:xfrm>
-            <a:off x="777240" y="621792"/>
-            <a:ext cx="10698480" cy="685800"/>
+            <a:off x="731520" y="1600200"/>
+            <a:ext cx="10698480" cy="960120"/>
           </a:xfrm>
           <a:prstGeom prst="rect">
             <a:avLst/>
@@ -4486,34 +4382,33 @@
           <a:noFill/>
         </p:spPr>
         <p:txBody>
-          <a:bodyPr wrap="none">
+          <a:bodyPr wrap="square">
             <a:spAutoFit/>
           </a:bodyPr>
           <a:lstStyle/>
           <a:p>
             <a:pPr algn="l"/>
             <a:r>
-              <a:rPr sz="3400" b="1">
+              <a:rPr sz="1700" b="0">
                 <a:solidFill>
                   <a:srgbClr val="FFFFFF"/>
                 </a:solidFill>
-                <a:latin typeface="Arial"/>
               </a:rPr>
-              <a:t>Hands-On Exercise</a:t>
-            </a:r>
-          </a:p>
-        </p:txBody>
-      </p:sp>
-      <p:sp>
-        <p:nvSpPr>
-          <p:cNvPr id="4" name="TextBox 3"/>
+              <a:t>  E-discovery is the process by which parties in a legal case must provide relevant documents to each other. It often involves searching acros</a:t>
+            </a:r>
+          </a:p>
+        </p:txBody>
+      </p:sp>
+      <p:sp>
+        <p:nvSpPr>
+          <p:cNvPr id="5" name="TextBox 4"/>
           <p:cNvSpPr txBox="1"/>
           <p:nvPr/>
         </p:nvSpPr>
         <p:spPr>
           <a:xfrm>
-            <a:off x="960120" y="1965960"/>
-            <a:ext cx="10241280" cy="4160520"/>
+            <a:off x="731520" y="2651760"/>
+            <a:ext cx="10698480" cy="960120"/>
           </a:xfrm>
           <a:prstGeom prst="rect">
             <a:avLst/>
@@ -4526,81 +4421,28 @@
           </a:bodyPr>
           <a:lstStyle/>
           <a:p>
-            <a:pPr>
-              <a:spcAft>
-                <a:spcPts val="1300"/>
-              </a:spcAft>
-              <a:defRPr sz="2500">
-                <a:solidFill>
-                  <a:srgbClr val="D4D4D8"/>
-                </a:solidFill>
-                <a:latin typeface="Arial"/>
-              </a:defRPr>
-            </a:pPr>
-            <a:r>
-              <a:t>Define a document redaction tool with a document path and PII type list</a:t>
-            </a:r>
-          </a:p>
-          <a:p>
-            <a:pPr>
-              <a:spcAft>
-                <a:spcPts val="1300"/>
-              </a:spcAft>
-              <a:defRPr sz="2500">
-                <a:solidFill>
-                  <a:srgbClr val="D4D4D8"/>
-                </a:solidFill>
-                <a:latin typeface="Arial"/>
-              </a:defRPr>
-            </a:pPr>
-            <a:r>
-              <a:t>Implement a mock regex redaction service for SSNs and names</a:t>
-            </a:r>
-          </a:p>
-          <a:p>
-            <a:pPr>
-              <a:spcAft>
-                <a:spcPts val="1300"/>
-              </a:spcAft>
-              <a:defRPr sz="2500">
-                <a:solidFill>
-                  <a:srgbClr val="D4D4D8"/>
-                </a:solidFill>
-                <a:latin typeface="Arial"/>
-              </a:defRPr>
-            </a:pPr>
-            <a:r>
-              <a:t>Inspect the before-and-after file output for redaction correctness</a:t>
-            </a:r>
-          </a:p>
-          <a:p>
-            <a:pPr>
-              <a:spcAft>
-                <a:spcPts val="1300"/>
-              </a:spcAft>
-              <a:defRPr sz="2500">
-                <a:solidFill>
-                  <a:srgbClr val="D4D4D8"/>
-                </a:solidFill>
-                <a:latin typeface="Arial"/>
-              </a:defRPr>
-            </a:pPr>
-            <a:r>
-              <a:t>Explain how the audit log remains tamper-proof without storing sensitive content</a:t>
-            </a:r>
-          </a:p>
-        </p:txBody>
-      </p:sp>
-      <p:sp>
-        <p:nvSpPr>
-          <p:cNvPr id="5" name="TextBox 4"/>
+            <a:pPr algn="l"/>
+            <a:r>
+              <a:rPr sz="1700" b="0">
+                <a:solidFill>
+                  <a:srgbClr val="FFFFFF"/>
+                </a:solidFill>
+              </a:rPr>
+              <a:t>  model="claude-sonnet-4-6"</a:t>
+            </a:r>
+          </a:p>
+        </p:txBody>
+      </p:sp>
+      <p:sp>
+        <p:nvSpPr>
+          <p:cNvPr id="6" name="TextBox 5"/>
           <p:cNvSpPr txBox="1"/>
           <p:nvPr/>
         </p:nvSpPr>
         <p:spPr>
           <a:xfrm>
-            <a:off x="822960" y="6263640"/>
-            <a:ext cx="6583680" cy="256032"/>
+            <a:off x="731520" y="3703320"/>
+            <a:ext cx="10698480" cy="960120"/>
           </a:xfrm>
           <a:prstGeom prst="rect">
             <a:avLst/>
@@ -4608,34 +4450,33 @@
           <a:noFill/>
         </p:spPr>
         <p:txBody>
-          <a:bodyPr wrap="none">
+          <a:bodyPr wrap="square">
             <a:spAutoFit/>
           </a:bodyPr>
           <a:lstStyle/>
           <a:p>
             <a:pPr algn="l"/>
             <a:r>
-              <a:rPr sz="1200" b="0">
-                <a:solidFill>
-                  <a:srgbClr val="A1A1AA"/>
-                </a:solidFill>
-                <a:latin typeface="Arial"/>
+              <a:rPr sz="1700" b="0">
+                <a:solidFill>
+                  <a:srgbClr val="FFFFFF"/>
+                </a:solidFill>
               </a:rPr>
-              <a:t>academy.kspl.tech | Koenig AI Academy</a:t>
-            </a:r>
-          </a:p>
-        </p:txBody>
-      </p:sp>
-      <p:sp>
-        <p:nvSpPr>
-          <p:cNvPr id="6" name="TextBox 5"/>
+              <a:t>  system="You are an expert MCP server designer."</a:t>
+            </a:r>
+          </a:p>
+        </p:txBody>
+      </p:sp>
+      <p:sp>
+        <p:nvSpPr>
+          <p:cNvPr id="7" name="TextBox 6"/>
           <p:cNvSpPr txBox="1"/>
           <p:nvPr/>
         </p:nvSpPr>
         <p:spPr>
           <a:xfrm>
-            <a:off x="10744200" y="6199632"/>
-            <a:ext cx="685800" cy="256032"/>
+            <a:off x="731520" y="4754880"/>
+            <a:ext cx="10698480" cy="960120"/>
           </a:xfrm>
           <a:prstGeom prst="rect">
             <a:avLst/>
@@ -4643,20 +4484,53 @@
           <a:noFill/>
         </p:spPr>
         <p:txBody>
-          <a:bodyPr wrap="none">
+          <a:bodyPr wrap="square">
             <a:spAutoFit/>
           </a:bodyPr>
           <a:lstStyle/>
           <a:p>
-            <a:pPr algn="r"/>
-            <a:r>
-              <a:rPr sz="1200" b="0">
+            <a:pPr algn="l"/>
+            <a:r>
+              <a:rPr sz="1700" b="0">
+                <a:solidFill>
+                  <a:srgbClr val="FFFFFF"/>
+                </a:solidFill>
+              </a:rPr>
+              <a:t>  prompt="Design a hypothetical teaching schema for an e-discovery search tool called search_discovery_vault. It should take a matter_id and a</a:t>
+            </a:r>
+          </a:p>
+        </p:txBody>
+      </p:sp>
+      <p:sp>
+        <p:nvSpPr>
+          <p:cNvPr id="8" name="TextBox 7"/>
+          <p:cNvSpPr txBox="1"/>
+          <p:nvPr/>
+        </p:nvSpPr>
+        <p:spPr>
+          <a:xfrm>
+            <a:off x="731520" y="6263640"/>
+            <a:ext cx="10698480" cy="365760"/>
+          </a:xfrm>
+          <a:prstGeom prst="rect">
+            <a:avLst/>
+          </a:prstGeom>
+          <a:noFill/>
+        </p:spPr>
+        <p:txBody>
+          <a:bodyPr wrap="square">
+            <a:spAutoFit/>
+          </a:bodyPr>
+          <a:lstStyle/>
+          <a:p>
+            <a:pPr algn="l"/>
+            <a:r>
+              <a:rPr sz="1000" b="0">
                 <a:solidFill>
                   <a:srgbClr val="A1A1AA"/>
                 </a:solidFill>
-                <a:latin typeface="Arial"/>
               </a:rPr>
-              <a:t>6/7</a:t>
+              <a:t>academy.kspl.tech | Koenig AI Academy</a:t>
             </a:r>
           </a:p>
         </p:txBody>
@@ -4689,57 +4563,14 @@
       <p:grpSpPr/>
       <p:sp>
         <p:nvSpPr>
-          <p:cNvPr id="2" name="Rectangle 1"/>
-          <p:cNvSpPr/>
-          <p:nvPr/>
-        </p:nvSpPr>
-        <p:spPr>
-          <a:xfrm>
-            <a:off x="0" y="0"/>
-            <a:ext cx="12191695" cy="109728"/>
-          </a:xfrm>
-          <a:prstGeom prst="rect">
-            <a:avLst/>
-          </a:prstGeom>
-          <a:solidFill>
-            <a:srgbClr val="A1A1AA"/>
-          </a:solidFill>
-          <a:ln>
-            <a:noFill/>
-          </a:ln>
-        </p:spPr>
-        <p:style>
-          <a:lnRef idx="1">
-            <a:schemeClr val="accent1"/>
-          </a:lnRef>
-          <a:fillRef idx="3">
-            <a:schemeClr val="accent1"/>
-          </a:fillRef>
-          <a:effectRef idx="2">
-            <a:schemeClr val="accent1"/>
-          </a:effectRef>
-          <a:fontRef idx="minor">
-            <a:schemeClr val="lt1"/>
-          </a:fontRef>
-        </p:style>
-        <p:txBody>
-          <a:bodyPr rtlCol="0" anchor="ctr"/>
-          <a:lstStyle/>
-          <a:p>
-            <a:pPr algn="ctr"/>
-          </a:p>
-        </p:txBody>
-      </p:sp>
-      <p:sp>
-        <p:nvSpPr>
-          <p:cNvPr id="3" name="TextBox 2"/>
+          <p:cNvPr id="2" name="TextBox 1"/>
           <p:cNvSpPr txBox="1"/>
           <p:nvPr/>
         </p:nvSpPr>
         <p:spPr>
           <a:xfrm>
-            <a:off x="777240" y="621792"/>
-            <a:ext cx="10698480" cy="685800"/>
+            <a:off x="914400" y="2011680"/>
+            <a:ext cx="10332720" cy="914400"/>
           </a:xfrm>
           <a:prstGeom prst="rect">
             <a:avLst/>
@@ -4747,18 +4578,17 @@
           <a:noFill/>
         </p:spPr>
         <p:txBody>
-          <a:bodyPr wrap="none">
+          <a:bodyPr wrap="square">
             <a:spAutoFit/>
           </a:bodyPr>
           <a:lstStyle/>
           <a:p>
-            <a:pPr algn="l"/>
+            <a:pPr algn="ctr"/>
             <a:r>
               <a:rPr sz="3400" b="1">
                 <a:solidFill>
                   <a:srgbClr val="FFFFFF"/>
                 </a:solidFill>
-                <a:latin typeface="Arial"/>
               </a:rPr>
               <a:t>Try it next</a:t>
             </a:r>
@@ -4767,14 +4597,14 @@
       </p:sp>
       <p:sp>
         <p:nvSpPr>
-          <p:cNvPr id="4" name="TextBox 3"/>
+          <p:cNvPr id="3" name="TextBox 2"/>
           <p:cNvSpPr txBox="1"/>
           <p:nvPr/>
         </p:nvSpPr>
         <p:spPr>
           <a:xfrm>
-            <a:off x="960120" y="1965960"/>
-            <a:ext cx="10241280" cy="4160520"/>
+            <a:off x="914400" y="3200400"/>
+            <a:ext cx="10332720" cy="1097280"/>
           </a:xfrm>
           <a:prstGeom prst="rect">
             <a:avLst/>
@@ -4787,81 +4617,28 @@
           </a:bodyPr>
           <a:lstStyle/>
           <a:p>
-            <a:pPr>
-              <a:spcAft>
-                <a:spcPts val="1300"/>
-              </a:spcAft>
-              <a:defRPr sz="2500">
-                <a:solidFill>
-                  <a:srgbClr val="D4D4D8"/>
-                </a:solidFill>
-                <a:latin typeface="Arial"/>
-              </a:defRPr>
-            </a:pPr>
-            <a:r>
-              <a:t>Apply the same secure-boundary pattern to the capstone connector project</a:t>
-            </a:r>
-          </a:p>
-          <a:p>
-            <a:pPr>
-              <a:spcAft>
-                <a:spcPts val="1300"/>
-              </a:spcAft>
-              <a:defRPr sz="2500">
-                <a:solidFill>
-                  <a:srgbClr val="D4D4D8"/>
-                </a:solidFill>
-                <a:latin typeface="Arial"/>
-              </a:defRPr>
-            </a:pPr>
-            <a:r>
-              <a:t>Combine redaction, authorization, residency, and audit logs before model analysis</a:t>
-            </a:r>
-          </a:p>
-          <a:p>
-            <a:pPr>
-              <a:spcAft>
-                <a:spcPts val="1300"/>
-              </a:spcAft>
-              <a:defRPr sz="2500">
-                <a:solidFill>
-                  <a:srgbClr val="D4D4D8"/>
-                </a:solidFill>
-                <a:latin typeface="Arial"/>
-              </a:defRPr>
-            </a:pPr>
-            <a:r>
-              <a:t>Treat compliance as part of the tool contract, not an after-the-fact review</a:t>
-            </a:r>
-          </a:p>
-          <a:p>
-            <a:pPr>
-              <a:spcAft>
-                <a:spcPts val="1300"/>
-              </a:spcAft>
-              <a:defRPr sz="2500">
-                <a:solidFill>
-                  <a:srgbClr val="D4D4D8"/>
-                </a:solidFill>
-                <a:latin typeface="Arial"/>
-              </a:defRPr>
-            </a:pPr>
-            <a:r>
-              <a:t>Next: build production-grade agentic connectors from these patterns</a:t>
-            </a:r>
-          </a:p>
-        </p:txBody>
-      </p:sp>
-      <p:sp>
-        <p:nvSpPr>
-          <p:cNvPr id="5" name="TextBox 4"/>
+            <a:pPr algn="ctr"/>
+            <a:r>
+              <a:rPr sz="2000" b="0">
+                <a:solidFill>
+                  <a:srgbClr val="A1A1AA"/>
+                </a:solidFill>
+              </a:rPr>
+              <a:t>Deploy a gateway with RBAC, rate limits, and JSONL auditing</a:t>
+            </a:r>
+          </a:p>
+        </p:txBody>
+      </p:sp>
+      <p:sp>
+        <p:nvSpPr>
+          <p:cNvPr id="4" name="TextBox 3"/>
           <p:cNvSpPr txBox="1"/>
           <p:nvPr/>
         </p:nvSpPr>
         <p:spPr>
           <a:xfrm>
-            <a:off x="822960" y="6263640"/>
-            <a:ext cx="6583680" cy="256032"/>
+            <a:off x="731520" y="6263640"/>
+            <a:ext cx="10698480" cy="365760"/>
           </a:xfrm>
           <a:prstGeom prst="rect">
             <a:avLst/>
@@ -4869,55 +4646,19 @@
           <a:noFill/>
         </p:spPr>
         <p:txBody>
-          <a:bodyPr wrap="none">
+          <a:bodyPr wrap="square">
             <a:spAutoFit/>
           </a:bodyPr>
           <a:lstStyle/>
           <a:p>
             <a:pPr algn="l"/>
             <a:r>
-              <a:rPr sz="1200" b="0">
+              <a:rPr sz="1000" b="0">
                 <a:solidFill>
                   <a:srgbClr val="A1A1AA"/>
                 </a:solidFill>
-                <a:latin typeface="Arial"/>
               </a:rPr>
               <a:t>academy.kspl.tech | Koenig AI Academy</a:t>
-            </a:r>
-          </a:p>
-        </p:txBody>
-      </p:sp>
-      <p:sp>
-        <p:nvSpPr>
-          <p:cNvPr id="6" name="TextBox 5"/>
-          <p:cNvSpPr txBox="1"/>
-          <p:nvPr/>
-        </p:nvSpPr>
-        <p:spPr>
-          <a:xfrm>
-            <a:off x="10744200" y="6199632"/>
-            <a:ext cx="685800" cy="256032"/>
-          </a:xfrm>
-          <a:prstGeom prst="rect">
-            <a:avLst/>
-          </a:prstGeom>
-          <a:noFill/>
-        </p:spPr>
-        <p:txBody>
-          <a:bodyPr wrap="none">
-            <a:spAutoFit/>
-          </a:bodyPr>
-          <a:lstStyle/>
-          <a:p>
-            <a:pPr algn="r"/>
-            <a:r>
-              <a:rPr sz="1200" b="0">
-                <a:solidFill>
-                  <a:srgbClr val="A1A1AA"/>
-                </a:solidFill>
-                <a:latin typeface="Arial"/>
-              </a:rPr>
-              <a:t>7/7</a:t>
             </a:r>
           </a:p>
         </p:txBody>

</xml_diff>